<commit_message>
Extract PowerPoint diagram text and connections for RAG
</commit_message>
<xml_diff>
--- a/docs/APIDocs/office2md/examples/powerpoint-complex/input.pptx
+++ b/docs/APIDocs/office2md/examples/powerpoint-complex/input.pptx
@@ -4176,7 +4176,7 @@
             </a:pPr>
             <a:r>
               <a:rPr lang="en-US" sz="3200"/>
-              <a:t>図は画像と説明文として残す</a:t>
+              <a:t>図中の文字を検索可能な本文へ</a:t>
             </a:r>
             <a:endParaRPr lang="ja-JP"/>
           </a:p>
@@ -4344,7 +4344,7 @@
             </a:pPr>
             <a:r>
               <a:rPr lang="en-US" sz="2400"/>
-              <a:t>図内の文字は画像説明に含め、本文に重ねて出力しません。</a:t>
+              <a:t>図内の文字は本文へ。接続先が保存されていない線の関係は推測しません。</a:t>
             </a:r>
             <a:endParaRPr lang="ja-JP"/>
           </a:p>

</xml_diff>

<commit_message>
Publish API docs and expand Office2MD examples
</commit_message>
<xml_diff>
--- a/docs/APIDocs/office2md/examples/powerpoint-complex/input.pptx
+++ b/docs/APIDocs/office2md/examples/powerpoint-complex/input.pptx
@@ -13,6 +13,8 @@
     <p:sldId id="258" r:id="rId11"/>
     <p:sldId id="259" r:id="rId12"/>
     <p:sldId id="260" r:id="rId13"/>
+    <p:sldId id="261" r:id="rId14"/>
+    <p:sldId id="262" r:id="rId15"/>
   </p:sldIdLst>
   <p:sldSz cx="12192000" cy="6858000"/>
   <p:notesSz cx="6858000" cy="9144000"/>
@@ -4431,6 +4433,36 @@
           </a:prstGeom>
         </p:spPr>
       </p:pic>
+      <p:sp>
+        <p:nvSpPr>
+          <p:cNvPr name="TextBox 4" id="4"/>
+          <p:cNvSpPr txBox="true"/>
+          <p:nvPr/>
+        </p:nvSpPr>
+        <p:spPr>
+          <a:xfrm>
+            <a:off x="9334500" y="1905000"/>
+            <a:ext cx="2413000" cy="3556000"/>
+          </a:xfrm>
+          <a:prstGeom prst="rect">
+            <a:avLst/>
+          </a:prstGeom>
+        </p:spPr>
+        <p:txBody>
+          <a:bodyPr anchor="t" rtlCol="false"/>
+          <a:lstStyle/>
+          <a:p>
+            <a:pPr algn="l">
+              <a:defRPr/>
+            </a:pPr>
+            <a:r>
+              <a:rPr lang="en-US" sz="1900"/>
+              <a:t>画像は埋め込みデータを参照し、代替説明も残します。</a:t>
+            </a:r>
+            <a:endParaRPr lang="ja-JP"/>
+          </a:p>
+        </p:txBody>
+      </p:sp>
     </p:spTree>
   </p:cSld>
   <p:clrMapOvr>
@@ -4440,6 +4472,1014 @@
 </file>
 
 <file path=ppt/slides/slide5.xml><?xml version="1.0" encoding="utf-8"?>
+<p:sld xmlns:p="http://schemas.openxmlformats.org/presentationml/2006/main" xmlns:a="http://schemas.openxmlformats.org/drawingml/2006/main">
+  <p:cSld>
+    <p:spTree>
+      <p:nvGrpSpPr>
+        <p:cNvPr id="1" name=""/>
+        <p:cNvGrpSpPr/>
+        <p:nvPr/>
+      </p:nvGrpSpPr>
+      <p:grpSpPr>
+        <a:xfrm>
+          <a:off x="0" y="0"/>
+          <a:ext cx="0" cy="0"/>
+          <a:chOff x="0" y="0"/>
+          <a:chExt cx="0" cy="0"/>
+        </a:xfrm>
+      </p:grpSpPr>
+      <p:sp>
+        <p:nvSpPr>
+          <p:cNvPr name="TextBox 2" id="2"/>
+          <p:cNvSpPr txBox="true"/>
+          <p:nvPr>
+            <p:ph type="title"/>
+          </p:nvPr>
+        </p:nvSpPr>
+        <p:spPr>
+          <a:xfrm>
+            <a:off x="508000" y="317500"/>
+            <a:ext cx="11176000" cy="762000"/>
+          </a:xfrm>
+          <a:prstGeom prst="rect">
+            <a:avLst/>
+          </a:prstGeom>
+        </p:spPr>
+        <p:txBody>
+          <a:bodyPr anchor="t" rtlCol="false"/>
+          <a:lstStyle/>
+          <a:p>
+            <a:pPr algn="l">
+              <a:defRPr/>
+            </a:pPr>
+            <a:r>
+              <a:rPr lang="en-US" sz="3200"/>
+              <a:t>条件別の対応を表で比較</a:t>
+            </a:r>
+            <a:endParaRPr lang="ja-JP"/>
+          </a:p>
+        </p:txBody>
+      </p:sp>
+      <p:sp>
+        <p:nvSpPr>
+          <p:cNvPr name="TextBox 3" id="3"/>
+          <p:cNvSpPr txBox="true"/>
+          <p:nvPr/>
+        </p:nvSpPr>
+        <p:spPr>
+          <a:xfrm>
+            <a:off x="508000" y="1143000"/>
+            <a:ext cx="11049000" cy="609600"/>
+          </a:xfrm>
+          <a:prstGeom prst="rect">
+            <a:avLst/>
+          </a:prstGeom>
+        </p:spPr>
+        <p:txBody>
+          <a:bodyPr anchor="t" rtlCol="false"/>
+          <a:lstStyle/>
+          <a:p>
+            <a:pPr algn="l">
+              <a:defRPr/>
+            </a:pPr>
+            <a:r>
+              <a:rPr lang="en-US" sz="2000"/>
+              <a:t>区分・条件・担当・処理を1行ずつ対応付けます。結合行の値は開始セルに保持します。</a:t>
+            </a:r>
+            <a:endParaRPr lang="ja-JP"/>
+          </a:p>
+        </p:txBody>
+      </p:sp>
+      <p:graphicFrame>
+        <p:nvGraphicFramePr>
+          <p:cNvPr name="Table 4" id="4"/>
+          <p:cNvGraphicFramePr>
+            <a:graphicFrameLocks noGrp="true"/>
+          </p:cNvGraphicFramePr>
+          <p:nvPr/>
+        </p:nvGraphicFramePr>
+        <p:xfrm>
+          <a:off x="508000" y="1905000"/>
+          <a:ext cx="11049000" cy="3492500"/>
+        </p:xfrm>
+        <a:graphic>
+          <a:graphicData uri="http://schemas.openxmlformats.org/drawingml/2006/table">
+            <a:tbl>
+              <a:tblPr/>
+              <a:tblGrid>
+                <a:gridCol w="2667000"/>
+                <a:gridCol w="3048000"/>
+                <a:gridCol w="2667000"/>
+                <a:gridCol w="2667000"/>
+              </a:tblGrid>
+              <a:tr h="698500">
+                <a:tc>
+                  <a:txBody>
+                    <a:bodyPr anchor="t" rtlCol="false"/>
+                    <a:lstStyle/>
+                    <a:p>
+                      <a:pPr algn="l">
+                        <a:defRPr/>
+                      </a:pPr>
+                      <a:r>
+                        <a:rPr lang="en-US" sz="2000"/>
+                        <a:t>区分</a:t>
+                      </a:r>
+                      <a:endParaRPr lang="en-US" sz="1100"/>
+                    </a:p>
+                  </a:txBody>
+                  <a:tcPr>
+                    <a:lnL>
+                      <a:noFill/>
+                    </a:lnL>
+                    <a:lnR>
+                      <a:noFill/>
+                    </a:lnR>
+                    <a:lnT>
+                      <a:noFill/>
+                    </a:lnT>
+                    <a:lnB>
+                      <a:noFill/>
+                    </a:lnB>
+                    <a:solidFill>
+                      <a:srgbClr val="DAE9F2"/>
+                    </a:solidFill>
+                  </a:tcPr>
+                </a:tc>
+                <a:tc>
+                  <a:txBody>
+                    <a:bodyPr anchor="t" rtlCol="false"/>
+                    <a:lstStyle/>
+                    <a:p>
+                      <a:pPr algn="l">
+                        <a:defRPr/>
+                      </a:pPr>
+                      <a:r>
+                        <a:rPr lang="en-US" sz="2000"/>
+                        <a:t>条件</a:t>
+                      </a:r>
+                      <a:endParaRPr lang="en-US" sz="1100"/>
+                    </a:p>
+                  </a:txBody>
+                  <a:tcPr>
+                    <a:lnL>
+                      <a:noFill/>
+                    </a:lnL>
+                    <a:lnR>
+                      <a:noFill/>
+                    </a:lnR>
+                    <a:lnT>
+                      <a:noFill/>
+                    </a:lnT>
+                    <a:lnB>
+                      <a:noFill/>
+                    </a:lnB>
+                    <a:solidFill>
+                      <a:srgbClr val="DAE9F2"/>
+                    </a:solidFill>
+                  </a:tcPr>
+                </a:tc>
+                <a:tc>
+                  <a:txBody>
+                    <a:bodyPr anchor="t" rtlCol="false"/>
+                    <a:lstStyle/>
+                    <a:p>
+                      <a:pPr algn="l">
+                        <a:defRPr/>
+                      </a:pPr>
+                      <a:r>
+                        <a:rPr lang="en-US" sz="2000"/>
+                        <a:t>担当</a:t>
+                      </a:r>
+                      <a:endParaRPr lang="en-US" sz="1100"/>
+                    </a:p>
+                  </a:txBody>
+                  <a:tcPr>
+                    <a:lnL>
+                      <a:noFill/>
+                    </a:lnL>
+                    <a:lnR>
+                      <a:noFill/>
+                    </a:lnR>
+                    <a:lnT>
+                      <a:noFill/>
+                    </a:lnT>
+                    <a:lnB>
+                      <a:noFill/>
+                    </a:lnB>
+                    <a:solidFill>
+                      <a:srgbClr val="DAE9F2"/>
+                    </a:solidFill>
+                  </a:tcPr>
+                </a:tc>
+                <a:tc>
+                  <a:txBody>
+                    <a:bodyPr anchor="t" rtlCol="false"/>
+                    <a:lstStyle/>
+                    <a:p>
+                      <a:pPr algn="l">
+                        <a:defRPr/>
+                      </a:pPr>
+                      <a:r>
+                        <a:rPr lang="en-US" sz="2000"/>
+                        <a:t>処理</a:t>
+                      </a:r>
+                      <a:endParaRPr lang="en-US" sz="1100"/>
+                    </a:p>
+                  </a:txBody>
+                  <a:tcPr>
+                    <a:lnL>
+                      <a:noFill/>
+                    </a:lnL>
+                    <a:lnR>
+                      <a:noFill/>
+                    </a:lnR>
+                    <a:lnT>
+                      <a:noFill/>
+                    </a:lnT>
+                    <a:lnB>
+                      <a:noFill/>
+                    </a:lnB>
+                    <a:solidFill>
+                      <a:srgbClr val="DAE9F2"/>
+                    </a:solidFill>
+                  </a:tcPr>
+                </a:tc>
+              </a:tr>
+              <a:tr h="698500">
+                <a:tc>
+                  <a:txBody>
+                    <a:bodyPr anchor="t" rtlCol="false"/>
+                    <a:lstStyle/>
+                    <a:p>
+                      <a:pPr algn="l">
+                        <a:defRPr/>
+                      </a:pPr>
+                      <a:r>
+                        <a:rPr lang="en-US" sz="2000"/>
+                        <a:t>通常</a:t>
+                      </a:r>
+                      <a:endParaRPr lang="en-US" sz="1100"/>
+                    </a:p>
+                  </a:txBody>
+                  <a:tcPr>
+                    <a:lnL>
+                      <a:noFill/>
+                    </a:lnL>
+                    <a:lnR>
+                      <a:noFill/>
+                    </a:lnR>
+                    <a:lnT>
+                      <a:noFill/>
+                    </a:lnT>
+                    <a:lnB>
+                      <a:noFill/>
+                    </a:lnB>
+                  </a:tcPr>
+                </a:tc>
+                <a:tc>
+                  <a:txBody>
+                    <a:bodyPr anchor="t" rtlCol="false"/>
+                    <a:lstStyle/>
+                    <a:p>
+                      <a:pPr algn="l">
+                        <a:defRPr/>
+                      </a:pPr>
+                      <a:r>
+                        <a:rPr lang="en-US" sz="2000"/>
+                        <a:t>資料あり</a:t>
+                      </a:r>
+                      <a:endParaRPr lang="en-US" sz="1100"/>
+                    </a:p>
+                  </a:txBody>
+                  <a:tcPr>
+                    <a:lnL>
+                      <a:noFill/>
+                    </a:lnL>
+                    <a:lnR>
+                      <a:noFill/>
+                    </a:lnR>
+                    <a:lnT>
+                      <a:noFill/>
+                    </a:lnT>
+                    <a:lnB>
+                      <a:noFill/>
+                    </a:lnB>
+                  </a:tcPr>
+                </a:tc>
+                <a:tc>
+                  <a:txBody>
+                    <a:bodyPr anchor="t" rtlCol="false"/>
+                    <a:lstStyle/>
+                    <a:p>
+                      <a:pPr algn="l">
+                        <a:defRPr/>
+                      </a:pPr>
+                      <a:r>
+                        <a:rPr lang="en-US" sz="2000"/>
+                        <a:t>受付</a:t>
+                      </a:r>
+                      <a:endParaRPr lang="en-US" sz="1100"/>
+                    </a:p>
+                  </a:txBody>
+                  <a:tcPr>
+                    <a:lnL>
+                      <a:noFill/>
+                    </a:lnL>
+                    <a:lnR>
+                      <a:noFill/>
+                    </a:lnR>
+                    <a:lnT>
+                      <a:noFill/>
+                    </a:lnT>
+                    <a:lnB>
+                      <a:noFill/>
+                    </a:lnB>
+                  </a:tcPr>
+                </a:tc>
+                <a:tc>
+                  <a:txBody>
+                    <a:bodyPr anchor="t" rtlCol="false"/>
+                    <a:lstStyle/>
+                    <a:p>
+                      <a:pPr algn="l">
+                        <a:defRPr/>
+                      </a:pPr>
+                      <a:r>
+                        <a:rPr lang="en-US" sz="2000"/>
+                        <a:t>当日確認</a:t>
+                      </a:r>
+                      <a:endParaRPr lang="en-US" sz="1100"/>
+                    </a:p>
+                  </a:txBody>
+                  <a:tcPr>
+                    <a:lnL>
+                      <a:noFill/>
+                    </a:lnL>
+                    <a:lnR>
+                      <a:noFill/>
+                    </a:lnR>
+                    <a:lnT>
+                      <a:noFill/>
+                    </a:lnT>
+                    <a:lnB>
+                      <a:noFill/>
+                    </a:lnB>
+                  </a:tcPr>
+                </a:tc>
+              </a:tr>
+              <a:tr h="698500">
+                <a:tc>
+                  <a:txBody>
+                    <a:bodyPr anchor="t" rtlCol="false"/>
+                    <a:lstStyle/>
+                    <a:p>
+                      <a:pPr algn="l">
+                        <a:defRPr/>
+                      </a:pPr>
+                      <a:r>
+                        <a:rPr lang="en-US" sz="2000"/>
+                        <a:t>差戻し</a:t>
+                      </a:r>
+                      <a:endParaRPr lang="en-US" sz="1100"/>
+                    </a:p>
+                  </a:txBody>
+                  <a:tcPr>
+                    <a:lnL>
+                      <a:noFill/>
+                    </a:lnL>
+                    <a:lnR>
+                      <a:noFill/>
+                    </a:lnR>
+                    <a:lnT>
+                      <a:noFill/>
+                    </a:lnT>
+                    <a:lnB>
+                      <a:noFill/>
+                    </a:lnB>
+                  </a:tcPr>
+                </a:tc>
+                <a:tc>
+                  <a:txBody>
+                    <a:bodyPr anchor="t" rtlCol="false"/>
+                    <a:lstStyle/>
+                    <a:p>
+                      <a:pPr algn="l">
+                        <a:defRPr/>
+                      </a:pPr>
+                      <a:r>
+                        <a:rPr lang="en-US" sz="2000"/>
+                        <a:t>添付不足</a:t>
+                      </a:r>
+                      <a:endParaRPr lang="en-US" sz="1100"/>
+                    </a:p>
+                  </a:txBody>
+                  <a:tcPr>
+                    <a:lnL>
+                      <a:noFill/>
+                    </a:lnL>
+                    <a:lnR>
+                      <a:noFill/>
+                    </a:lnR>
+                    <a:lnT>
+                      <a:noFill/>
+                    </a:lnT>
+                    <a:lnB>
+                      <a:noFill/>
+                    </a:lnB>
+                  </a:tcPr>
+                </a:tc>
+                <a:tc>
+                  <a:txBody>
+                    <a:bodyPr anchor="t" rtlCol="false"/>
+                    <a:lstStyle/>
+                    <a:p>
+                      <a:pPr algn="l">
+                        <a:defRPr/>
+                      </a:pPr>
+                      <a:r>
+                        <a:rPr lang="en-US" sz="2000"/>
+                        <a:t>申請者</a:t>
+                      </a:r>
+                      <a:endParaRPr lang="en-US" sz="1100"/>
+                    </a:p>
+                  </a:txBody>
+                  <a:tcPr>
+                    <a:lnL>
+                      <a:noFill/>
+                    </a:lnL>
+                    <a:lnR>
+                      <a:noFill/>
+                    </a:lnR>
+                    <a:lnT>
+                      <a:noFill/>
+                    </a:lnT>
+                    <a:lnB>
+                      <a:noFill/>
+                    </a:lnB>
+                  </a:tcPr>
+                </a:tc>
+                <a:tc>
+                  <a:txBody>
+                    <a:bodyPr anchor="t" rtlCol="false"/>
+                    <a:lstStyle/>
+                    <a:p>
+                      <a:pPr algn="l">
+                        <a:defRPr/>
+                      </a:pPr>
+                      <a:r>
+                        <a:rPr lang="en-US" sz="2000"/>
+                        <a:t>再提出</a:t>
+                      </a:r>
+                      <a:endParaRPr lang="en-US" sz="1100"/>
+                    </a:p>
+                  </a:txBody>
+                  <a:tcPr>
+                    <a:lnL>
+                      <a:noFill/>
+                    </a:lnL>
+                    <a:lnR>
+                      <a:noFill/>
+                    </a:lnR>
+                    <a:lnT>
+                      <a:noFill/>
+                    </a:lnT>
+                    <a:lnB>
+                      <a:noFill/>
+                    </a:lnB>
+                  </a:tcPr>
+                </a:tc>
+              </a:tr>
+              <a:tr h="698500">
+                <a:tc gridSpan="2">
+                  <a:txBody>
+                    <a:bodyPr anchor="t" rtlCol="false"/>
+                    <a:lstStyle/>
+                    <a:p>
+                      <a:pPr algn="l">
+                        <a:defRPr/>
+                      </a:pPr>
+                      <a:r>
+                        <a:rPr lang="en-US" sz="2000"/>
+                        <a:t>共通の補足</a:t>
+                      </a:r>
+                      <a:endParaRPr lang="en-US" sz="1100"/>
+                    </a:p>
+                  </a:txBody>
+                  <a:tcPr>
+                    <a:lnL>
+                      <a:noFill/>
+                    </a:lnL>
+                    <a:lnR>
+                      <a:noFill/>
+                    </a:lnR>
+                    <a:lnT>
+                      <a:noFill/>
+                    </a:lnT>
+                    <a:lnB>
+                      <a:noFill/>
+                    </a:lnB>
+                  </a:tcPr>
+                </a:tc>
+                <a:tc hMerge="true">
+                  <a:txBody>
+                    <a:bodyPr anchor="t" rtlCol="false"/>
+                    <a:lstStyle/>
+                    <a:p>
+                      <a:pPr algn="l">
+                        <a:defRPr/>
+                      </a:pPr>
+                      <a:r>
+                        <a:rPr lang="en-US" sz="2000"/>
+                        <a:t/>
+                      </a:r>
+                      <a:endParaRPr lang="en-US" sz="1100"/>
+                    </a:p>
+                  </a:txBody>
+                  <a:tcPr>
+                    <a:lnL>
+                      <a:noFill/>
+                    </a:lnL>
+                    <a:lnR>
+                      <a:noFill/>
+                    </a:lnR>
+                    <a:lnT>
+                      <a:noFill/>
+                    </a:lnT>
+                    <a:lnB>
+                      <a:noFill/>
+                    </a:lnB>
+                  </a:tcPr>
+                </a:tc>
+                <a:tc>
+                  <a:txBody>
+                    <a:bodyPr anchor="t" rtlCol="false"/>
+                    <a:lstStyle/>
+                    <a:p>
+                      <a:pPr algn="l">
+                        <a:defRPr/>
+                      </a:pPr>
+                      <a:r>
+                        <a:rPr lang="en-US" sz="2000"/>
+                        <a:t>管理者</a:t>
+                      </a:r>
+                      <a:endParaRPr lang="en-US" sz="1100"/>
+                    </a:p>
+                  </a:txBody>
+                  <a:tcPr>
+                    <a:lnL>
+                      <a:noFill/>
+                    </a:lnL>
+                    <a:lnR>
+                      <a:noFill/>
+                    </a:lnR>
+                    <a:lnT>
+                      <a:noFill/>
+                    </a:lnT>
+                    <a:lnB>
+                      <a:noFill/>
+                    </a:lnB>
+                  </a:tcPr>
+                </a:tc>
+                <a:tc>
+                  <a:txBody>
+                    <a:bodyPr anchor="t" rtlCol="false"/>
+                    <a:lstStyle/>
+                    <a:p>
+                      <a:pPr algn="l">
+                        <a:defRPr/>
+                      </a:pPr>
+                      <a:r>
+                        <a:rPr lang="en-US" sz="2000"/>
+                        <a:t>期限は営業日</a:t>
+                      </a:r>
+                      <a:endParaRPr lang="en-US" sz="1100"/>
+                    </a:p>
+                  </a:txBody>
+                  <a:tcPr>
+                    <a:lnL>
+                      <a:noFill/>
+                    </a:lnL>
+                    <a:lnR>
+                      <a:noFill/>
+                    </a:lnR>
+                    <a:lnT>
+                      <a:noFill/>
+                    </a:lnT>
+                    <a:lnB>
+                      <a:noFill/>
+                    </a:lnB>
+                  </a:tcPr>
+                </a:tc>
+              </a:tr>
+              <a:tr h="698500">
+                <a:tc>
+                  <a:txBody>
+                    <a:bodyPr anchor="t" rtlCol="false"/>
+                    <a:lstStyle/>
+                    <a:p>
+                      <a:pPr algn="l">
+                        <a:defRPr/>
+                      </a:pPr>
+                      <a:r>
+                        <a:rPr lang="en-US" sz="2000"/>
+                        <a:t>例外</a:t>
+                      </a:r>
+                      <a:endParaRPr lang="en-US" sz="1100"/>
+                    </a:p>
+                  </a:txBody>
+                  <a:tcPr>
+                    <a:lnL>
+                      <a:noFill/>
+                    </a:lnL>
+                    <a:lnR>
+                      <a:noFill/>
+                    </a:lnR>
+                    <a:lnT>
+                      <a:noFill/>
+                    </a:lnT>
+                    <a:lnB>
+                      <a:noFill/>
+                    </a:lnB>
+                  </a:tcPr>
+                </a:tc>
+                <a:tc>
+                  <a:txBody>
+                    <a:bodyPr anchor="t" rtlCol="false"/>
+                    <a:lstStyle/>
+                    <a:p>
+                      <a:pPr algn="l">
+                        <a:defRPr/>
+                      </a:pPr>
+                      <a:r>
+                        <a:rPr lang="en-US" sz="2000"/>
+                        <a:t>期限超過</a:t>
+                      </a:r>
+                      <a:endParaRPr lang="en-US" sz="1100"/>
+                    </a:p>
+                  </a:txBody>
+                  <a:tcPr>
+                    <a:lnL>
+                      <a:noFill/>
+                    </a:lnL>
+                    <a:lnR>
+                      <a:noFill/>
+                    </a:lnR>
+                    <a:lnT>
+                      <a:noFill/>
+                    </a:lnT>
+                    <a:lnB>
+                      <a:noFill/>
+                    </a:lnB>
+                  </a:tcPr>
+                </a:tc>
+                <a:tc>
+                  <a:txBody>
+                    <a:bodyPr anchor="t" rtlCol="false"/>
+                    <a:lstStyle/>
+                    <a:p>
+                      <a:pPr algn="l">
+                        <a:defRPr/>
+                      </a:pPr>
+                      <a:r>
+                        <a:rPr lang="en-US" sz="2000"/>
+                        <a:t>責任者</a:t>
+                      </a:r>
+                      <a:endParaRPr lang="en-US" sz="1100"/>
+                    </a:p>
+                  </a:txBody>
+                  <a:tcPr>
+                    <a:lnL>
+                      <a:noFill/>
+                    </a:lnL>
+                    <a:lnR>
+                      <a:noFill/>
+                    </a:lnR>
+                    <a:lnT>
+                      <a:noFill/>
+                    </a:lnT>
+                    <a:lnB>
+                      <a:noFill/>
+                    </a:lnB>
+                  </a:tcPr>
+                </a:tc>
+                <a:tc>
+                  <a:txBody>
+                    <a:bodyPr anchor="t" rtlCol="false"/>
+                    <a:lstStyle/>
+                    <a:p>
+                      <a:pPr algn="l">
+                        <a:defRPr/>
+                      </a:pPr>
+                      <a:r>
+                        <a:rPr lang="en-US" sz="2000"/>
+                        <a:t>翌朝判断</a:t>
+                      </a:r>
+                      <a:endParaRPr lang="en-US" sz="1100"/>
+                    </a:p>
+                  </a:txBody>
+                  <a:tcPr>
+                    <a:lnL>
+                      <a:noFill/>
+                    </a:lnL>
+                    <a:lnR>
+                      <a:noFill/>
+                    </a:lnR>
+                    <a:lnT>
+                      <a:noFill/>
+                    </a:lnT>
+                    <a:lnB>
+                      <a:noFill/>
+                    </a:lnB>
+                  </a:tcPr>
+                </a:tc>
+              </a:tr>
+            </a:tbl>
+          </a:graphicData>
+        </a:graphic>
+      </p:graphicFrame>
+      <p:sp>
+        <p:nvSpPr>
+          <p:cNvPr name="TextBox 5" id="5"/>
+          <p:cNvSpPr txBox="true"/>
+          <p:nvPr/>
+        </p:nvSpPr>
+        <p:spPr>
+          <a:xfrm>
+            <a:off x="571500" y="5778500"/>
+            <a:ext cx="10795000" cy="558800"/>
+          </a:xfrm>
+          <a:prstGeom prst="rect">
+            <a:avLst/>
+          </a:prstGeom>
+        </p:spPr>
+        <p:txBody>
+          <a:bodyPr anchor="t" rtlCol="false"/>
+          <a:lstStyle/>
+          <a:p>
+            <a:pPr algn="l">
+              <a:defRPr/>
+            </a:pPr>
+            <a:r>
+              <a:rPr lang="en-US" sz="2000"/>
+              <a:t>補足：差戻し後は同じ申請番号で再判定します。</a:t>
+            </a:r>
+            <a:endParaRPr lang="ja-JP"/>
+          </a:p>
+        </p:txBody>
+      </p:sp>
+    </p:spTree>
+  </p:cSld>
+  <p:clrMapOvr>
+    <a:masterClrMapping/>
+  </p:clrMapOvr>
+</p:sld>
+</file>
+
+<file path=ppt/slides/slide6.xml><?xml version="1.0" encoding="utf-8"?>
+<p:sld xmlns:p="http://schemas.openxmlformats.org/presentationml/2006/main" xmlns:a="http://schemas.openxmlformats.org/drawingml/2006/main">
+  <p:cSld>
+    <p:spTree>
+      <p:nvGrpSpPr>
+        <p:cNvPr id="1" name=""/>
+        <p:cNvGrpSpPr/>
+        <p:nvPr/>
+      </p:nvGrpSpPr>
+      <p:grpSpPr>
+        <a:xfrm>
+          <a:off x="0" y="0"/>
+          <a:ext cx="0" cy="0"/>
+          <a:chOff x="0" y="0"/>
+          <a:chExt cx="0" cy="0"/>
+        </a:xfrm>
+      </p:grpSpPr>
+      <p:sp>
+        <p:nvSpPr>
+          <p:cNvPr name="TextBox 2" id="2"/>
+          <p:cNvSpPr txBox="true"/>
+          <p:nvPr>
+            <p:ph type="title"/>
+          </p:nvPr>
+        </p:nvSpPr>
+        <p:spPr>
+          <a:xfrm>
+            <a:off x="508000" y="317500"/>
+            <a:ext cx="11176000" cy="762000"/>
+          </a:xfrm>
+          <a:prstGeom prst="rect">
+            <a:avLst/>
+          </a:prstGeom>
+        </p:spPr>
+        <p:txBody>
+          <a:bodyPr anchor="t" rtlCol="false"/>
+          <a:lstStyle/>
+          <a:p>
+            <a:pPr algn="l">
+              <a:defRPr/>
+            </a:pPr>
+            <a:r>
+              <a:rPr lang="en-US" sz="3200"/>
+              <a:t>レビュー経路の図形と補足</a:t>
+            </a:r>
+            <a:endParaRPr lang="ja-JP"/>
+          </a:p>
+        </p:txBody>
+      </p:sp>
+      <p:grpSp>
+        <p:nvGrpSpPr>
+          <p:cNvPr name="Group 3" id="3"/>
+          <p:cNvGrpSpPr/>
+          <p:nvPr/>
+        </p:nvGrpSpPr>
+        <p:grpSpPr>
+          <a:xfrm>
+            <a:off x="762000" y="1651000"/>
+            <a:ext cx="10541000" cy="3175000"/>
+            <a:chOff x="0" y="0"/>
+            <a:chExt cx="10541000" cy="3175000"/>
+          </a:xfrm>
+        </p:grpSpPr>
+        <p:sp>
+          <p:nvSpPr>
+            <p:cNvPr name="AutoShape 4" id="4"/>
+            <p:cNvSpPr/>
+            <p:nvPr/>
+          </p:nvSpPr>
+          <p:spPr>
+            <a:xfrm>
+              <a:off x="0" y="698500"/>
+              <a:ext cx="2667000" cy="1651000"/>
+            </a:xfrm>
+            <a:prstGeom prst="roundRect">
+              <a:avLst/>
+            </a:prstGeom>
+            <a:solidFill>
+              <a:srgbClr val="DCEFFF"/>
+            </a:solidFill>
+          </p:spPr>
+          <p:txBody>
+            <a:bodyPr anchor="t" rtlCol="false"/>
+            <a:lstStyle/>
+            <a:p>
+              <a:pPr algn="l">
+                <a:defRPr/>
+              </a:pPr>
+              <a:r>
+                <a:rPr lang="en-US" sz="2600"/>
+                <a:t>申請を受付</a:t>
+              </a:r>
+              <a:endParaRPr lang="en-US" sz="1100"/>
+            </a:p>
+          </p:txBody>
+        </p:sp>
+        <p:sp>
+          <p:nvSpPr>
+            <p:cNvPr name="AutoShape 5" id="5"/>
+            <p:cNvSpPr/>
+            <p:nvPr/>
+          </p:nvSpPr>
+          <p:spPr>
+            <a:xfrm>
+              <a:off x="3937000" y="381000"/>
+              <a:ext cx="2413000" cy="2286000"/>
+            </a:xfrm>
+            <a:prstGeom prst="diamond">
+              <a:avLst/>
+            </a:prstGeom>
+            <a:solidFill>
+              <a:srgbClr val="FFEFD1"/>
+            </a:solidFill>
+          </p:spPr>
+          <p:txBody>
+            <a:bodyPr anchor="t" rtlCol="false"/>
+            <a:lstStyle/>
+            <a:p>
+              <a:pPr algn="l">
+                <a:defRPr/>
+              </a:pPr>
+              <a:r>
+                <a:rPr lang="en-US" sz="2400"/>
+                <a:t>資料を確認</a:t>
+              </a:r>
+              <a:endParaRPr lang="en-US" sz="1100"/>
+            </a:p>
+          </p:txBody>
+        </p:sp>
+        <p:sp>
+          <p:nvSpPr>
+            <p:cNvPr name="AutoShape 6" id="6"/>
+            <p:cNvSpPr/>
+            <p:nvPr/>
+          </p:nvSpPr>
+          <p:spPr>
+            <a:xfrm>
+              <a:off x="7747000" y="698500"/>
+              <a:ext cx="2667000" cy="1651000"/>
+            </a:xfrm>
+            <a:prstGeom prst="roundRect">
+              <a:avLst/>
+            </a:prstGeom>
+            <a:solidFill>
+              <a:srgbClr val="DEF4E1"/>
+            </a:solidFill>
+          </p:spPr>
+          <p:txBody>
+            <a:bodyPr anchor="t" rtlCol="false"/>
+            <a:lstStyle/>
+            <a:p>
+              <a:pPr algn="l">
+                <a:defRPr/>
+              </a:pPr>
+              <a:r>
+                <a:rPr lang="en-US" sz="2600"/>
+                <a:t>結果を通知</a:t>
+              </a:r>
+              <a:endParaRPr lang="en-US" sz="1100"/>
+            </a:p>
+          </p:txBody>
+        </p:sp>
+        <p:cxnSp>
+          <p:nvCxnSpPr>
+            <p:cNvPr name="Connector 7" id="7"/>
+            <p:cNvCxnSpPr/>
+            <p:nvPr/>
+          </p:nvCxnSpPr>
+          <p:spPr>
+            <a:xfrm>
+              <a:off x="2667000" y="1524000"/>
+              <a:ext cx="1270000" cy="0"/>
+            </a:xfrm>
+            <a:prstGeom prst="line">
+              <a:avLst/>
+            </a:prstGeom>
+            <a:ln w="38100">
+              <a:solidFill>
+                <a:srgbClr val="000000"/>
+              </a:solidFill>
+            </a:ln>
+          </p:spPr>
+        </p:cxnSp>
+        <p:cxnSp>
+          <p:nvCxnSpPr>
+            <p:cNvPr name="Connector 8" id="8"/>
+            <p:cNvCxnSpPr/>
+            <p:nvPr/>
+          </p:nvCxnSpPr>
+          <p:spPr>
+            <a:xfrm>
+              <a:off x="6350000" y="1524000"/>
+              <a:ext cx="1397000" cy="0"/>
+            </a:xfrm>
+            <a:prstGeom prst="line">
+              <a:avLst/>
+            </a:prstGeom>
+            <a:ln w="38100">
+              <a:solidFill>
+                <a:srgbClr val="000000"/>
+              </a:solidFill>
+            </a:ln>
+          </p:spPr>
+        </p:cxnSp>
+      </p:grpSp>
+      <p:sp>
+        <p:nvSpPr>
+          <p:cNvPr name="TextBox 9" id="9"/>
+          <p:cNvSpPr txBox="true"/>
+          <p:nvPr/>
+        </p:nvSpPr>
+        <p:spPr>
+          <a:xfrm>
+            <a:off x="698500" y="5334000"/>
+            <a:ext cx="10922000" cy="914400"/>
+          </a:xfrm>
+          <a:prstGeom prst="rect">
+            <a:avLst/>
+          </a:prstGeom>
+        </p:spPr>
+        <p:txBody>
+          <a:bodyPr anchor="t" rtlCol="false"/>
+          <a:lstStyle/>
+          <a:p>
+            <a:pPr algn="l">
+              <a:defRPr/>
+            </a:pPr>
+            <a:r>
+              <a:rPr lang="en-US" sz="2100"/>
+              <a:t>図形のラベルを本文から検索できます。線の関係は確定できた場合だけ記録します。</a:t>
+            </a:r>
+            <a:endParaRPr lang="ja-JP"/>
+          </a:p>
+        </p:txBody>
+      </p:sp>
+    </p:spTree>
+  </p:cSld>
+  <p:clrMapOvr>
+    <a:masterClrMapping/>
+  </p:clrMapOvr>
+</p:sld>
+</file>
+
+<file path=ppt/slides/slide7.xml><?xml version="1.0" encoding="utf-8"?>
 <p:sld xmlns:p="http://schemas.openxmlformats.org/presentationml/2006/main" xmlns:a="http://schemas.openxmlformats.org/drawingml/2006/main" show="false">
   <p:cSld>
     <p:spTree>

</xml_diff>